<commit_message>
Actualización de la presentación de Caporal AI para la Fase 4
Se actualiza el archivo de presentación de la entrega correspondiente a la Fase 4.
</commit_message>
<xml_diff>
--- a/docs/Caporal AI.pptx
+++ b/docs/Caporal AI.pptx
@@ -7838,148 +7838,6 @@
         <p:txBody>
           <a:bodyPr/>
           <a:lstStyle/>
-          <a:p>
-            <a:pPr marL="342900" indent="-342900">
-              <a:buFont typeface="Arial" panose="020B0604020202020204" pitchFamily="34" charset="0"/>
-              <a:buChar char="•"/>
-            </a:pPr>
-            <a:r>
-              <a:rPr lang="es-ES" dirty="0"/>
-              <a:t>**Notas del Presentador:** *"En conclusión, Caporal AI trasciende el software de registro y se posiciona como una herramienta prescriptiva que cuida el bolsillo del ganadero. Hacia el futuro, el proyecto tiene un claro camino de escalabilidad: planeamos conectar el sistema a bolsas de valores agrícolas para actualizar precios en automático, y exploraremos tecnologías de Edge AI, permitiendo que el motor matemático corra en los celulares de las rancherías sin necesidad de internet. Muchas gracias por su atención, estamos a su disposición para cualquier pregunta."*</a:t>
-            </a:r>
-          </a:p>
-          <a:p>
-            <a:pPr marL="0" indent="0">
-              <a:buFont typeface="Arial" panose="020B0604020202020204" pitchFamily="34" charset="0"/>
-              <a:buNone/>
-            </a:pPr>
-            <a:endParaRPr lang="es-ES" dirty="0"/>
-          </a:p>
-          <a:p>
-            <a:pPr marL="342900" indent="-342900">
-              <a:buFont typeface="Arial" panose="020B0604020202020204" pitchFamily="34" charset="0"/>
-              <a:buChar char="•"/>
-            </a:pPr>
-            <a:r>
-              <a:rPr lang="es-ES" dirty="0"/>
-              <a:t>**Sugerencia Visual:** Iconos de escalabilidad: Una antena/nube (</a:t>
-            </a:r>
-            <a:r>
-              <a:rPr lang="es-ES" dirty="0" err="1"/>
-              <a:t>APIs</a:t>
-            </a:r>
-            <a:r>
-              <a:rPr lang="es-ES" dirty="0"/>
-              <a:t>), un celular (Edge AI) y un icono de granja (Expansión transversal).</a:t>
-            </a:r>
-          </a:p>
-          <a:p>
-            <a:pPr marL="342900" indent="-342900">
-              <a:buFont typeface="Arial" panose="020B0604020202020204" pitchFamily="34" charset="0"/>
-              <a:buChar char="•"/>
-            </a:pPr>
-            <a:endParaRPr lang="es-ES" dirty="0"/>
-          </a:p>
-          <a:p>
-            <a:pPr marL="0" indent="0">
-              <a:buFont typeface="Arial" panose="020B0604020202020204" pitchFamily="34" charset="0"/>
-              <a:buNone/>
-            </a:pPr>
-            <a:r>
-              <a:rPr lang="es-ES" dirty="0"/>
-              <a:t>### 💡 Reglas de Oro para la grabación (Según Clase S04):</a:t>
-            </a:r>
-          </a:p>
-          <a:p>
-            <a:pPr marL="0" indent="0">
-              <a:buFont typeface="Arial" panose="020B0604020202020204" pitchFamily="34" charset="0"/>
-              <a:buNone/>
-            </a:pPr>
-            <a:r>
-              <a:rPr lang="es-ES" dirty="0"/>
-              <a:t>1. **Practiquen para no exceder los 10 minutos cronometrados.**</a:t>
-            </a:r>
-          </a:p>
-          <a:p>
-            <a:pPr marL="0" indent="0">
-              <a:buFont typeface="Arial" panose="020B0604020202020204" pitchFamily="34" charset="0"/>
-              <a:buNone/>
-            </a:pPr>
-            <a:r>
-              <a:rPr lang="es-ES" dirty="0"/>
-              <a:t>2. **Repártanse equitativamente las diapositivas; todos deben hablar.**</a:t>
-            </a:r>
-          </a:p>
-          <a:p>
-            <a:pPr marL="0" indent="0">
-              <a:buFont typeface="Arial" panose="020B0604020202020204" pitchFamily="34" charset="0"/>
-              <a:buNone/>
-            </a:pPr>
-            <a:r>
-              <a:rPr lang="es-ES" dirty="0"/>
-              <a:t>3. **Usen OBS Studio o </a:t>
-            </a:r>
-            <a:r>
-              <a:rPr lang="es-ES" dirty="0" err="1"/>
-              <a:t>Teams</a:t>
-            </a:r>
-            <a:r>
-              <a:rPr lang="es-ES" dirty="0"/>
-              <a:t>/Zoom.** Compartan pantalla con sus **cámaras encendidas** en todo momento.</a:t>
-            </a:r>
-          </a:p>
-          <a:p>
-            <a:pPr marL="0" indent="0">
-              <a:buFont typeface="Arial" panose="020B0604020202020204" pitchFamily="34" charset="0"/>
-              <a:buNone/>
-            </a:pPr>
-            <a:r>
-              <a:rPr lang="es-ES" dirty="0"/>
-              <a:t>4. **NO LEAN.** El texto de la PPT es de apoyo; el guion es para que lo estudien, lo hagan suyo y lo expliquen con naturalidad. La rúbrica prohíbe terminantemente leer mecánicamente.</a:t>
-            </a:r>
-          </a:p>
-          <a:p>
-            <a:pPr marL="0" indent="0">
-              <a:buFont typeface="Arial" panose="020B0604020202020204" pitchFamily="34" charset="0"/>
-              <a:buNone/>
-            </a:pPr>
-            <a:endParaRPr lang="es-ES" dirty="0"/>
-          </a:p>
-          <a:p>
-            <a:pPr marL="0" marR="0" lvl="0" indent="0" algn="l" defTabSz="457200" rtl="0" eaLnBrk="0" fontAlgn="base" latinLnBrk="0" hangingPunct="0">
-              <a:lnSpc>
-                <a:spcPct val="125000"/>
-              </a:lnSpc>
-              <a:spcBef>
-                <a:spcPct val="0"/>
-              </a:spcBef>
-              <a:spcAft>
-                <a:spcPct val="0"/>
-              </a:spcAft>
-              <a:buClrTx/>
-              <a:buSzTx/>
-              <a:buFont typeface="Arial" panose="020B0604020202020204" pitchFamily="34" charset="0"/>
-              <a:buNone/>
-              <a:tabLst/>
-              <a:defRPr/>
-            </a:pPr>
-            <a:r>
-              <a:rPr lang="es-ES" sz="2400" b="1" kern="1200" dirty="0">
-                <a:solidFill>
-                  <a:srgbClr val="000000"/>
-                </a:solidFill>
-                <a:effectLst/>
-                <a:latin typeface="Avenir" charset="0"/>
-                <a:ea typeface="Avenir" charset="0"/>
-                <a:cs typeface="Avenir" charset="0"/>
-                <a:sym typeface="Avenir Roman" charset="0"/>
-              </a:rPr>
-              <a:t>----------------------------------------------------------------------------------------------------------------------------------------------------------------------------------------------</a:t>
-            </a:r>
-            <a:endParaRPr lang="en-US" dirty="0">
-              <a:effectLst/>
-            </a:endParaRPr>
-          </a:p>
           <a:p>
             <a:pPr marL="0" indent="0">
               <a:buFont typeface="Arial" panose="020B0604020202020204" pitchFamily="34" charset="0"/>
@@ -19043,7 +18901,31 @@
               <a:rPr lang="pt-BR" altLang="es-ES" dirty="0">
                 <a:sym typeface="Arial Narrow" panose="020B0606020202030204" pitchFamily="34" charset="0"/>
               </a:rPr>
-              <a:t>Objetivos Específicos: Motor matemático determinista (Simplex) e Interfaz de IA (RAG) en Arquitectura Hexagonal.</a:t>
+              <a:t>Objetivos Específicos: Motor matemático determinista (</a:t>
+            </a:r>
+            <a:r>
+              <a:rPr lang="pt-BR" altLang="es-ES" dirty="0" err="1">
+                <a:sym typeface="Arial Narrow" panose="020B0606020202030204" pitchFamily="34" charset="0"/>
+              </a:rPr>
+              <a:t>LinProg</a:t>
+            </a:r>
+            <a:r>
+              <a:rPr lang="pt-BR" altLang="es-ES" dirty="0">
+                <a:sym typeface="Arial Narrow" panose="020B0606020202030204" pitchFamily="34" charset="0"/>
+              </a:rPr>
+              <a:t>(</a:t>
+            </a:r>
+            <a:r>
+              <a:rPr lang="pt-BR" altLang="es-ES" dirty="0" err="1">
+                <a:sym typeface="Arial Narrow" panose="020B0606020202030204" pitchFamily="34" charset="0"/>
+              </a:rPr>
+              <a:t>HiGHS</a:t>
+            </a:r>
+            <a:r>
+              <a:rPr lang="pt-BR" altLang="es-ES" dirty="0">
+                <a:sym typeface="Arial Narrow" panose="020B0606020202030204" pitchFamily="34" charset="0"/>
+              </a:rPr>
+              <a:t>)) e Interfaz de IA (RAG) en Arquitectura Hexagonal.</a:t>
             </a:r>
           </a:p>
           <a:p>
@@ -22503,7 +22385,7 @@
         <p:spPr bwMode="auto">
           <a:xfrm>
             <a:off x="49064" y="764704"/>
-            <a:ext cx="3240360" cy="5632311"/>
+            <a:ext cx="3240360" cy="4524315"/>
           </a:xfrm>
           <a:prstGeom prst="rect">
             <a:avLst/>
@@ -22662,16 +22544,22 @@
               <a:buChar char="►"/>
             </a:pPr>
             <a:r>
-              <a:rPr lang="es-ES" altLang="es-ES" dirty="0" err="1">
+              <a:rPr lang="es-ES" altLang="es-ES" b="1" dirty="0" err="1">
                 <a:sym typeface="Arial Narrow" panose="020B0606020202030204" pitchFamily="34" charset="0"/>
               </a:rPr>
               <a:t>Backtesting</a:t>
+            </a:r>
+            <a:r>
+              <a:rPr lang="es-ES" altLang="es-ES" b="1" dirty="0">
+                <a:sym typeface="Arial Narrow" panose="020B0606020202030204" pitchFamily="34" charset="0"/>
+              </a:rPr>
+              <a:t> Histórico: </a:t>
             </a:r>
             <a:r>
               <a:rPr lang="es-ES" altLang="es-ES" dirty="0">
                 <a:sym typeface="Arial Narrow" panose="020B0606020202030204" pitchFamily="34" charset="0"/>
               </a:rPr>
-              <a:t> Histórico: Simulación retrospectiva a 90 días con inyección de volatilidad de precios.</a:t>
+              <a:t>Simulación retrospectiva a 90 días con inyección de volatilidad de precios.</a:t>
             </a:r>
           </a:p>
           <a:p>
@@ -22698,10 +22586,16 @@
               <a:buChar char="►"/>
             </a:pPr>
             <a:r>
+              <a:rPr lang="es-ES" altLang="es-ES" b="1" dirty="0">
+                <a:sym typeface="Arial Narrow" panose="020B0606020202030204" pitchFamily="34" charset="0"/>
+              </a:rPr>
+              <a:t>Validación Biológica (KPI-3): </a:t>
+            </a:r>
+            <a:r>
               <a:rPr lang="es-ES" altLang="es-ES" dirty="0">
                 <a:sym typeface="Arial Narrow" panose="020B0606020202030204" pitchFamily="34" charset="0"/>
               </a:rPr>
-              <a:t>Validación Biológica (KPI-3): 0.00 violaciones nutricionales (Restricciones NRC cumplidas).</a:t>
+              <a:t>0.00 violaciones nutricionales</a:t>
             </a:r>
           </a:p>
           <a:p>
@@ -22713,9 +22607,23 @@
               <a:buFont typeface="Arial Narrow" panose="020B0606020202030204" pitchFamily="34" charset="0"/>
               <a:buChar char="►"/>
             </a:pPr>
-            <a:endParaRPr lang="es-ES" altLang="es-ES" dirty="0">
-              <a:sym typeface="Arial Narrow" panose="020B0606020202030204" pitchFamily="34" charset="0"/>
-            </a:endParaRPr>
+            <a:r>
+              <a:rPr lang="es-ES" altLang="es-ES" b="1" dirty="0">
+                <a:sym typeface="Arial Narrow" panose="020B0606020202030204" pitchFamily="34" charset="0"/>
+              </a:rPr>
+              <a:t>Calidad de la IA (KPI-1 y 2):</a:t>
+            </a:r>
+            <a:br>
+              <a:rPr lang="es-ES" altLang="es-ES" b="1" dirty="0">
+                <a:sym typeface="Arial Narrow" panose="020B0606020202030204" pitchFamily="34" charset="0"/>
+              </a:rPr>
+            </a:br>
+            <a:r>
+              <a:rPr lang="es-ES" altLang="es-ES" dirty="0">
+                <a:sym typeface="Arial Narrow" panose="020B0606020202030204" pitchFamily="34" charset="0"/>
+              </a:rPr>
+              <a:t>100% de respuestas técnicas con citas verificables</a:t>
+            </a:r>
           </a:p>
           <a:p>
             <a:pPr eaLnBrk="1">
@@ -22727,39 +22635,16 @@
               <a:buChar char="►"/>
             </a:pPr>
             <a:r>
+              <a:rPr lang="es-ES" altLang="es-ES" b="1" dirty="0">
+                <a:sym typeface="Arial Narrow" panose="020B0606020202030204" pitchFamily="34" charset="0"/>
+              </a:rPr>
+              <a:t>Éxito Económico (KPI-7): </a:t>
+            </a:r>
+            <a:r>
               <a:rPr lang="es-ES" altLang="es-ES" dirty="0">
                 <a:sym typeface="Arial Narrow" panose="020B0606020202030204" pitchFamily="34" charset="0"/>
               </a:rPr>
-              <a:t>Calidad de la IA (KPI-1 y 2): &gt;92% de respuestas técnicas con citas verificables (Cero alucinaciones operativas).</a:t>
-            </a:r>
-          </a:p>
-          <a:p>
-            <a:pPr eaLnBrk="1">
-              <a:buClr>
-                <a:srgbClr val="0098CD"/>
-              </a:buClr>
-              <a:buSzPct val="50000"/>
-              <a:buFont typeface="Arial Narrow" panose="020B0606020202030204" pitchFamily="34" charset="0"/>
-              <a:buChar char="►"/>
-            </a:pPr>
-            <a:endParaRPr lang="es-ES" altLang="es-ES" dirty="0">
-              <a:sym typeface="Arial Narrow" panose="020B0606020202030204" pitchFamily="34" charset="0"/>
-            </a:endParaRPr>
-          </a:p>
-          <a:p>
-            <a:pPr eaLnBrk="1">
-              <a:buClr>
-                <a:srgbClr val="0098CD"/>
-              </a:buClr>
-              <a:buSzPct val="50000"/>
-              <a:buFont typeface="Arial Narrow" panose="020B0606020202030204" pitchFamily="34" charset="0"/>
-              <a:buChar char="►"/>
-            </a:pPr>
-            <a:r>
-              <a:rPr lang="es-ES" altLang="es-ES" dirty="0">
-                <a:sym typeface="Arial Narrow" panose="020B0606020202030204" pitchFamily="34" charset="0"/>
-              </a:rPr>
-              <a:t>Éxito Económico (KPI-7): Reducción de costos consistente vs. la dieta empírica tradicional.</a:t>
+              <a:t>Reducción de costos consistente.</a:t>
             </a:r>
             <a:endParaRPr lang="es-ES_tradnl" altLang="es-ES" dirty="0">
               <a:sym typeface="Arial Narrow" panose="020B0606020202030204" pitchFamily="34" charset="0"/>
@@ -22944,10 +22829,10 @@
       </p:sp>
       <p:pic>
         <p:nvPicPr>
-          <p:cNvPr id="3" name="Picture 2">
+          <p:cNvPr id="4" name="Picture 3">
             <a:extLst>
               <a:ext uri="{FF2B5EF4-FFF2-40B4-BE49-F238E27FC236}">
-                <a16:creationId xmlns:a16="http://schemas.microsoft.com/office/drawing/2014/main" id="{D7CA2393-09A2-0A67-B212-BF066F66A412}"/>
+                <a16:creationId xmlns:a16="http://schemas.microsoft.com/office/drawing/2014/main" id="{999D5AB8-36AE-8DD7-9AD3-611EBE782E8C}"/>
               </a:ext>
             </a:extLst>
           </p:cNvPr>
@@ -22964,38 +22849,8 @@
         </p:blipFill>
         <p:spPr>
           <a:xfrm>
-            <a:off x="3468879" y="1066021"/>
-            <a:ext cx="5493550" cy="1623094"/>
-          </a:xfrm>
-          <a:prstGeom prst="rect">
-            <a:avLst/>
-          </a:prstGeom>
-        </p:spPr>
-      </p:pic>
-      <p:pic>
-        <p:nvPicPr>
-          <p:cNvPr id="5" name="Picture 4">
-            <a:extLst>
-              <a:ext uri="{FF2B5EF4-FFF2-40B4-BE49-F238E27FC236}">
-                <a16:creationId xmlns:a16="http://schemas.microsoft.com/office/drawing/2014/main" id="{5D8296DA-9358-7FD1-08F9-9324E0ADD511}"/>
-              </a:ext>
-            </a:extLst>
-          </p:cNvPr>
-          <p:cNvPicPr>
-            <a:picLocks noChangeAspect="1"/>
-          </p:cNvPicPr>
-          <p:nvPr/>
-        </p:nvPicPr>
-        <p:blipFill>
-          <a:blip r:embed="rId4"/>
-          <a:stretch>
-            <a:fillRect/>
-          </a:stretch>
-        </p:blipFill>
-        <p:spPr>
-          <a:xfrm>
-            <a:off x="3197301" y="3140968"/>
-            <a:ext cx="5807182" cy="2815604"/>
+            <a:off x="3335312" y="2276872"/>
+            <a:ext cx="5759624" cy="3130582"/>
           </a:xfrm>
           <a:prstGeom prst="rect">
             <a:avLst/>
@@ -23576,10 +23431,16 @@
               <a:buChar char="►"/>
             </a:pPr>
             <a:r>
+              <a:rPr lang="es-ES" altLang="es-ES" b="1" dirty="0">
+                <a:sym typeface="Arial Narrow" panose="020B0606020202030204" pitchFamily="34" charset="0"/>
+              </a:rPr>
+              <a:t>Problema Resuelto: </a:t>
+            </a:r>
+            <a:r>
               <a:rPr lang="es-ES" altLang="es-ES" dirty="0">
                 <a:sym typeface="Arial Narrow" panose="020B0606020202030204" pitchFamily="34" charset="0"/>
               </a:rPr>
-              <a:t>Problema Resuelto: Democratización de la optimización matemática para el pequeño productor.</a:t>
+              <a:t>Democratización de la optimización matemática para el pequeño productor.</a:t>
             </a:r>
           </a:p>
           <a:p>
@@ -23608,10 +23469,21 @@
               <a:buChar char="►"/>
             </a:pPr>
             <a:r>
+              <a:rPr lang="es-ES" altLang="es-ES" b="1" dirty="0">
+                <a:sym typeface="Arial Narrow" panose="020B0606020202030204" pitchFamily="34" charset="0"/>
+              </a:rPr>
+              <a:t>Precisión Científica: </a:t>
+            </a:r>
+            <a:br>
+              <a:rPr lang="es-ES" altLang="es-ES" b="1" dirty="0">
+                <a:sym typeface="Arial Narrow" panose="020B0606020202030204" pitchFamily="34" charset="0"/>
+              </a:rPr>
+            </a:br>
+            <a:r>
               <a:rPr lang="es-ES" altLang="es-ES" dirty="0">
                 <a:sym typeface="Arial Narrow" panose="020B0606020202030204" pitchFamily="34" charset="0"/>
               </a:rPr>
-              <a:t>Precisión Científica: El cálculo determinista elimina el riesgo de la IA Generativa.</a:t>
+              <a:t>El cálculo determinista elimina el riesgo de la IA Generativa.</a:t>
             </a:r>
           </a:p>
           <a:p>
@@ -23839,7 +23711,7 @@
               <a:buSzPct val="50000"/>
             </a:pPr>
             <a:r>
-              <a:rPr lang="es-ES_tradnl" altLang="es-ES" dirty="0">
+              <a:rPr lang="es-ES_tradnl" altLang="es-ES" b="1" dirty="0">
                 <a:sym typeface="Arial Narrow" panose="020B0606020202030204" pitchFamily="34" charset="0"/>
               </a:rPr>
               <a:t>Trabajo Futuro:</a:t>
@@ -23953,7 +23825,7 @@
         </p:blipFill>
         <p:spPr>
           <a:xfrm>
-            <a:off x="251520" y="2924944"/>
+            <a:off x="593812" y="3045139"/>
             <a:ext cx="7956376" cy="3409875"/>
           </a:xfrm>
           <a:prstGeom prst="rect">

</xml_diff>